<commit_message>
feat(blockchain): implement cryptographic SHA-256 ledger, smart contracts, and interactive browser developer manual
</commit_message>
<xml_diff>
--- a/Multipurpose_SCM_AWS_Architecture.pptx
+++ b/Multipurpose_SCM_AWS_Architecture.pptx
@@ -11,6 +11,7 @@
     <p:sldId id="259" r:id="rId10"/>
     <p:sldId id="260" r:id="rId11"/>
     <p:sldId id="261" r:id="rId12"/>
+    <p:sldId id="262" r:id="rId13"/>
   </p:sldIdLst>
   <p:sldSz cx="12191695" cy="6858000" type="screen4x3"/>
   <p:notesSz cx="6858000" cy="9144000"/>
@@ -3145,7 +3146,7 @@
         <p:spPr>
           <a:xfrm>
             <a:off x="731520" y="1097280"/>
-            <a:ext cx="2926080" cy="411480"/>
+            <a:ext cx="3474720" cy="411480"/>
           </a:xfrm>
           <a:prstGeom prst="roundRect">
             <a:avLst/>
@@ -3178,14 +3179,14 @@
           <a:lstStyle/>
           <a:p>
             <a:pPr algn="ctr">
-              <a:defRPr sz="1100" b="1">
+              <a:defRPr sz="1050" b="1">
                 <a:solidFill>
                   <a:srgbClr val="FF9900"/>
                 </a:solidFill>
               </a:defRPr>
             </a:pPr>
             <a:r>
-              <a:t>☁️ AWS ENTERPRISE CLOUD PROJECT</a:t>
+              <a:t>☁️ AWS ENTERPRISE CLOUD + BLOCKCHAIN</a:t>
             </a:r>
           </a:p>
         </p:txBody>
@@ -3230,14 +3231,14 @@
           <a:p>
             <a:br/>
             <a:pPr>
-              <a:defRPr sz="1800">
+              <a:defRPr sz="1700">
                 <a:solidFill>
                   <a:srgbClr val="22D3EE"/>
                 </a:solidFill>
               </a:defRPr>
             </a:pPr>
             <a:r>
-              <a:t>Event-Driven Cloud Architecture with Amazon DynamoDB, SQS, SNS, S3 &amp; IoT Core</a:t>
+              <a:t>Event-Driven Cloud Architecture with AWS Cloud Services &amp; Cryptographic Blockchain Ledger</a:t>
             </a:r>
           </a:p>
         </p:txBody>
@@ -3284,26 +3285,26 @@
           <a:lstStyle/>
           <a:p>
             <a:pPr algn="ctr">
-              <a:defRPr sz="1400" b="1">
+              <a:defRPr sz="1300" b="1">
                 <a:solidFill>
                   <a:srgbClr val="FF9900"/>
                 </a:solidFill>
               </a:defRPr>
             </a:pPr>
             <a:r>
-              <a:t>NoSQL DynamoDB</a:t>
-            </a:r>
-          </a:p>
-          <a:p>
-            <a:pPr>
-              <a:defRPr sz="1100">
+              <a:t>NoSQL DynamoDB &amp; SQS</a:t>
+            </a:r>
+          </a:p>
+          <a:p>
+            <a:pPr>
+              <a:defRPr sz="1050">
                 <a:solidFill>
                   <a:srgbClr val="94A3B8"/>
                 </a:solidFill>
               </a:defRPr>
             </a:pPr>
             <a:r>
-              <a:t>High-throughput, sub-10ms stock ledgers across global hubs</a:t>
+              <a:t>Sub-10ms stock ledgers &amp; decoupled async order queue buffer</a:t>
             </a:r>
           </a:p>
         </p:txBody>
@@ -3350,26 +3351,26 @@
           <a:lstStyle/>
           <a:p>
             <a:pPr algn="ctr">
-              <a:defRPr sz="1400" b="1">
+              <a:defRPr sz="1300" b="1">
                 <a:solidFill>
                   <a:srgbClr val="FF9900"/>
                 </a:solidFill>
               </a:defRPr>
             </a:pPr>
             <a:r>
-              <a:t>Asynchronous SQS</a:t>
-            </a:r>
-          </a:p>
-          <a:p>
-            <a:pPr>
-              <a:defRPr sz="1100">
+              <a:t>IoT Cold-Chain Stream</a:t>
+            </a:r>
+          </a:p>
+          <a:p>
+            <a:pPr>
+              <a:defRPr sz="1050">
                 <a:solidFill>
                   <a:srgbClr val="94A3B8"/>
                 </a:solidFill>
               </a:defRPr>
             </a:pPr>
             <a:r>
-              <a:t>Decoupled order pipeline with DLQ zero-loss guarantees</a:t>
+              <a:t>Real-time sensor telemetry &amp; automated Amazon SNS breach alerts</a:t>
             </a:r>
           </a:p>
         </p:txBody>
@@ -3416,26 +3417,26 @@
           <a:lstStyle/>
           <a:p>
             <a:pPr algn="ctr">
-              <a:defRPr sz="1400" b="1">
+              <a:defRPr sz="1300" b="1">
                 <a:solidFill>
                   <a:srgbClr val="FF9900"/>
                 </a:solidFill>
               </a:defRPr>
             </a:pPr>
             <a:r>
-              <a:t>IoT Cold-Chain Stream</a:t>
-            </a:r>
-          </a:p>
-          <a:p>
-            <a:pPr>
-              <a:defRPr sz="1100">
+              <a:t>Immutable Blockchain</a:t>
+            </a:r>
+          </a:p>
+          <a:p>
+            <a:pPr>
+              <a:defRPr sz="1050">
                 <a:solidFill>
                   <a:srgbClr val="94A3B8"/>
                 </a:solidFill>
               </a:defRPr>
             </a:pPr>
             <a:r>
-              <a:t>Real-time sensor telemetry &amp; automated SNS breach alerts</a:t>
+              <a:t>SHA-256 Merkle chain, PoA consensus &amp; automated escrow smart contracts</a:t>
             </a:r>
           </a:p>
         </p:txBody>
@@ -3531,7 +3532,7 @@
               </a:defRPr>
             </a:pPr>
             <a:r>
-              <a:t>AWS CLOUD SUPPLY CHAIN PLATFORM</a:t>
+              <a:t>AWS CLOUD &amp; BLOCKCHAIN PLATFORM</a:t>
             </a:r>
           </a:p>
         </p:txBody>
@@ -3706,7 +3707,7 @@
               </a:defRPr>
             </a:pPr>
             <a:r>
-              <a:t>• Supplier Governance Lags:</a:t>
+              <a:t>• Lack of Multi-Party Trust:</a:t>
             </a:r>
           </a:p>
           <a:p>
@@ -3718,7 +3719,7 @@
               </a:defRPr>
             </a:pPr>
             <a:r>
-              <a:t>    Untracked vendor lead times disrupt mission-critical manufacturing.</a:t>
+              <a:t>    Traditional centralized databases allow unverified edits in custody disputes.</a:t>
             </a:r>
           </a:p>
         </p:txBody>
@@ -3820,7 +3821,7 @@
               </a:defRPr>
             </a:pPr>
             <a:r>
-              <a:t>    ESD cleanroom warehousing, serial tracking for automotive AI chips, and rapid transit.</a:t>
+              <a:t>    ESD cleanroom warehousing, serial tracking for automotive AI chips, and shock monitoring.</a:t>
             </a:r>
           </a:p>
           <a:p>
@@ -3870,7 +3871,7 @@
               </a:defRPr>
             </a:pPr>
             <a:r>
-              <a:t>    Diagnostic PCR reagents, enzyme viability tracking, and batch lot traceability.</a:t>
+              <a:t>    Diagnostic PCR reagents, enzyme viability tracking, and cryptographic chain-of-custody.</a:t>
             </a:r>
           </a:p>
         </p:txBody>
@@ -3966,7 +3967,7 @@
               </a:defRPr>
             </a:pPr>
             <a:r>
-              <a:t>AWS CLOUD SUPPLY CHAIN PLATFORM</a:t>
+              <a:t>IMMUTABLE LEDGER &amp; SMART CONTRACTS</a:t>
             </a:r>
           </a:p>
         </p:txBody>
@@ -4001,7 +4002,7 @@
               </a:defRPr>
             </a:pPr>
             <a:r>
-              <a:t>Enterprise AWS Cloud Architecture Mappings</a:t>
+              <a:t>Cryptographic Blockchain Ledger &amp; Smart Contracts</a:t>
             </a:r>
           </a:p>
         </p:txBody>
@@ -4015,7 +4016,7 @@
         <p:spPr>
           <a:xfrm>
             <a:off x="731520" y="1554480"/>
-            <a:ext cx="3383280" cy="2194560"/>
+            <a:ext cx="3383280" cy="4389120"/>
           </a:xfrm>
           <a:prstGeom prst="roundRect">
             <a:avLst/>
@@ -4025,7 +4026,7 @@
           </a:solidFill>
           <a:ln w="19050">
             <a:solidFill>
-              <a:srgbClr val="FF9900"/>
+              <a:srgbClr val="A855F7"/>
             </a:solidFill>
           </a:ln>
         </p:spPr>
@@ -4048,39 +4049,27 @@
           <a:lstStyle/>
           <a:p>
             <a:pPr algn="ctr">
-              <a:defRPr sz="1400" b="1">
-                <a:solidFill>
-                  <a:srgbClr val="FF9900"/>
-                </a:solidFill>
-              </a:defRPr>
-            </a:pPr>
-            <a:r>
-              <a:t>Amazon DynamoDB</a:t>
-            </a:r>
-          </a:p>
-          <a:p>
-            <a:pPr>
-              <a:defRPr sz="900" b="1">
-                <a:solidFill>
-                  <a:srgbClr val="94A3B8"/>
-                </a:solidFill>
-              </a:defRPr>
-            </a:pPr>
-            <a:r>
-              <a:t>NOSQL OPERATIONAL STORE</a:t>
+              <a:defRPr sz="1500" b="1">
+                <a:solidFill>
+                  <a:srgbClr val="A855F7"/>
+                </a:solidFill>
+              </a:defRPr>
+            </a:pPr>
+            <a:r>
+              <a:t>Immutable SHA-256 Chain</a:t>
             </a:r>
           </a:p>
           <a:p>
             <a:br/>
             <a:pPr>
-              <a:defRPr sz="1050">
+              <a:defRPr sz="1100">
                 <a:solidFill>
                   <a:srgbClr val="F1F5F9"/>
                 </a:solidFill>
               </a:defRPr>
             </a:pPr>
             <a:r>
-              <a:t>Low-latency schema for Warehouses, Orders, Shipments, and Time-series Telemetry. Supports GSIs and automated TTL.</a:t>
+              <a:t>Every block contains an index, timestamp, transaction Merkle tree, nonce, and the previous block's SHA-256 hash. Any tampering invalidates the entire chain.</a:t>
             </a:r>
           </a:p>
         </p:txBody>
@@ -4094,7 +4083,7 @@
         <p:spPr>
           <a:xfrm>
             <a:off x="4343400" y="1554480"/>
-            <a:ext cx="3383280" cy="2194560"/>
+            <a:ext cx="3383280" cy="4389120"/>
           </a:xfrm>
           <a:prstGeom prst="roundRect">
             <a:avLst/>
@@ -4127,39 +4116,27 @@
           <a:lstStyle/>
           <a:p>
             <a:pPr algn="ctr">
-              <a:defRPr sz="1400" b="1">
+              <a:defRPr sz="1500" b="1">
                 <a:solidFill>
                   <a:srgbClr val="22D3EE"/>
                 </a:solidFill>
               </a:defRPr>
             </a:pPr>
             <a:r>
-              <a:t>Amazon SQS</a:t>
-            </a:r>
-          </a:p>
-          <a:p>
-            <a:pPr>
-              <a:defRPr sz="900" b="1">
-                <a:solidFill>
-                  <a:srgbClr val="94A3B8"/>
-                </a:solidFill>
-              </a:defRPr>
-            </a:pPr>
-            <a:r>
-              <a:t>DECOUPLED ORDER QUEUE</a:t>
+              <a:t>Proof-of-Authority Consensus</a:t>
             </a:r>
           </a:p>
           <a:p>
             <a:br/>
             <a:pPr>
-              <a:defRPr sz="1050">
+              <a:defRPr sz="1100">
                 <a:solidFill>
                   <a:srgbClr val="F1F5F9"/>
                 </a:solidFill>
               </a:defRPr>
             </a:pPr>
             <a:r>
-              <a:t>Buffers incoming customer orders. Employs Dead-Letter Queue (DLQ) with maxReceiveCount=3 to isolate poison messages.</a:t>
+              <a:t>Designed around Amazon Managed Blockchain (AMB) / Hyperledger Fabric standards, ensuring deterministic block finality with high transaction throughput.</a:t>
             </a:r>
           </a:p>
         </p:txBody>
@@ -4173,86 +4150,7 @@
         <p:spPr>
           <a:xfrm>
             <a:off x="7955280" y="1554480"/>
-            <a:ext cx="3383280" cy="2194560"/>
-          </a:xfrm>
-          <a:prstGeom prst="roundRect">
-            <a:avLst/>
-          </a:prstGeom>
-          <a:solidFill>
-            <a:srgbClr val="1A2438"/>
-          </a:solidFill>
-          <a:ln w="19050">
-            <a:solidFill>
-              <a:srgbClr val="F59E0B"/>
-            </a:solidFill>
-          </a:ln>
-        </p:spPr>
-        <p:style>
-          <a:lnRef idx="1">
-            <a:schemeClr val="accent1"/>
-          </a:lnRef>
-          <a:fillRef idx="3">
-            <a:schemeClr val="accent1"/>
-          </a:fillRef>
-          <a:effectRef idx="2">
-            <a:schemeClr val="accent1"/>
-          </a:effectRef>
-          <a:fontRef idx="minor">
-            <a:schemeClr val="lt1"/>
-          </a:fontRef>
-        </p:style>
-        <p:txBody>
-          <a:bodyPr rtlCol="0" anchor="ctr" wrap="square"/>
-          <a:lstStyle/>
-          <a:p>
-            <a:pPr algn="ctr">
-              <a:defRPr sz="1400" b="1">
-                <a:solidFill>
-                  <a:srgbClr val="F59E0B"/>
-                </a:solidFill>
-              </a:defRPr>
-            </a:pPr>
-            <a:r>
-              <a:t>Amazon SNS</a:t>
-            </a:r>
-          </a:p>
-          <a:p>
-            <a:pPr>
-              <a:defRPr sz="900" b="1">
-                <a:solidFill>
-                  <a:srgbClr val="94A3B8"/>
-                </a:solidFill>
-              </a:defRPr>
-            </a:pPr>
-            <a:r>
-              <a:t>PUB/SUB BROADCAST TOPIC</a:t>
-            </a:r>
-          </a:p>
-          <a:p>
-            <a:br/>
-            <a:pPr>
-              <a:defRPr sz="1050">
-                <a:solidFill>
-                  <a:srgbClr val="F1F5F9"/>
-                </a:solidFill>
-              </a:defRPr>
-            </a:pPr>
-            <a:r>
-              <a:t>Dispatches instant alerts for temperature violations (&gt;8°C), road shock damage, and inventory reorder point breaches.</a:t>
-            </a:r>
-          </a:p>
-        </p:txBody>
-      </p:sp>
-      <p:sp>
-        <p:nvSpPr>
-          <p:cNvPr id="8" name="Rounded Rectangle 7"/>
-          <p:cNvSpPr/>
-          <p:nvPr/>
-        </p:nvSpPr>
-        <p:spPr>
-          <a:xfrm>
-            <a:off x="731520" y="3977639"/>
-            <a:ext cx="3383280" cy="2194560"/>
+            <a:ext cx="3383280" cy="4389120"/>
           </a:xfrm>
           <a:prstGeom prst="roundRect">
             <a:avLst/>
@@ -4285,197 +4183,27 @@
           <a:lstStyle/>
           <a:p>
             <a:pPr algn="ctr">
-              <a:defRPr sz="1400" b="1">
+              <a:defRPr sz="1500" b="1">
                 <a:solidFill>
                   <a:srgbClr val="34D399"/>
                 </a:solidFill>
               </a:defRPr>
             </a:pPr>
             <a:r>
-              <a:t>Amazon S3</a:t>
-            </a:r>
-          </a:p>
-          <a:p>
-            <a:pPr>
-              <a:defRPr sz="900" b="1">
-                <a:solidFill>
-                  <a:srgbClr val="94A3B8"/>
-                </a:solidFill>
-              </a:defRPr>
-            </a:pPr>
-            <a:r>
-              <a:t>SECURE DOCUMENT LAKE</a:t>
+              <a:t>Automated Escrow Smart Contracts</a:t>
             </a:r>
           </a:p>
           <a:p>
             <a:br/>
             <a:pPr>
-              <a:defRPr sz="1050">
+              <a:defRPr sz="1100">
                 <a:solidFill>
                   <a:srgbClr val="F1F5F9"/>
                 </a:solidFill>
               </a:defRPr>
             </a:pPr>
             <a:r>
-              <a:t>Stores immutable digital invoices, bills of lading, and delivery signatures with AES-256 encryption and versioning.</a:t>
-            </a:r>
-          </a:p>
-        </p:txBody>
-      </p:sp>
-      <p:sp>
-        <p:nvSpPr>
-          <p:cNvPr id="9" name="Rounded Rectangle 8"/>
-          <p:cNvSpPr/>
-          <p:nvPr/>
-        </p:nvSpPr>
-        <p:spPr>
-          <a:xfrm>
-            <a:off x="4343400" y="3977639"/>
-            <a:ext cx="3383280" cy="2194560"/>
-          </a:xfrm>
-          <a:prstGeom prst="roundRect">
-            <a:avLst/>
-          </a:prstGeom>
-          <a:solidFill>
-            <a:srgbClr val="1A2438"/>
-          </a:solidFill>
-          <a:ln w="19050">
-            <a:solidFill>
-              <a:srgbClr val="A855F7"/>
-            </a:solidFill>
-          </a:ln>
-        </p:spPr>
-        <p:style>
-          <a:lnRef idx="1">
-            <a:schemeClr val="accent1"/>
-          </a:lnRef>
-          <a:fillRef idx="3">
-            <a:schemeClr val="accent1"/>
-          </a:fillRef>
-          <a:effectRef idx="2">
-            <a:schemeClr val="accent1"/>
-          </a:effectRef>
-          <a:fontRef idx="minor">
-            <a:schemeClr val="lt1"/>
-          </a:fontRef>
-        </p:style>
-        <p:txBody>
-          <a:bodyPr rtlCol="0" anchor="ctr" wrap="square"/>
-          <a:lstStyle/>
-          <a:p>
-            <a:pPr algn="ctr">
-              <a:defRPr sz="1400" b="1">
-                <a:solidFill>
-                  <a:srgbClr val="A855F7"/>
-                </a:solidFill>
-              </a:defRPr>
-            </a:pPr>
-            <a:r>
-              <a:t>AWS IoT Core</a:t>
-            </a:r>
-          </a:p>
-          <a:p>
-            <a:pPr>
-              <a:defRPr sz="900" b="1">
-                <a:solidFill>
-                  <a:srgbClr val="94A3B8"/>
-                </a:solidFill>
-              </a:defRPr>
-            </a:pPr>
-            <a:r>
-              <a:t>TELEMETRY RULES ENGINE</a:t>
-            </a:r>
-          </a:p>
-          <a:p>
-            <a:br/>
-            <a:pPr>
-              <a:defRPr sz="1050">
-                <a:solidFill>
-                  <a:srgbClr val="F1F5F9"/>
-                </a:solidFill>
-              </a:defRPr>
-            </a:pPr>
-            <a:r>
-              <a:t>Ingests live vehicle sensor metrics (temp, humidity, shock, GPS, battery) and forwards directly to DynamoDB.</a:t>
-            </a:r>
-          </a:p>
-        </p:txBody>
-      </p:sp>
-      <p:sp>
-        <p:nvSpPr>
-          <p:cNvPr id="10" name="Rounded Rectangle 9"/>
-          <p:cNvSpPr/>
-          <p:nvPr/>
-        </p:nvSpPr>
-        <p:spPr>
-          <a:xfrm>
-            <a:off x="7955280" y="3977639"/>
-            <a:ext cx="3383280" cy="2194560"/>
-          </a:xfrm>
-          <a:prstGeom prst="roundRect">
-            <a:avLst/>
-          </a:prstGeom>
-          <a:solidFill>
-            <a:srgbClr val="1A2438"/>
-          </a:solidFill>
-          <a:ln w="19050">
-            <a:solidFill>
-              <a:srgbClr val="3B82F6"/>
-            </a:solidFill>
-          </a:ln>
-        </p:spPr>
-        <p:style>
-          <a:lnRef idx="1">
-            <a:schemeClr val="accent1"/>
-          </a:lnRef>
-          <a:fillRef idx="3">
-            <a:schemeClr val="accent1"/>
-          </a:fillRef>
-          <a:effectRef idx="2">
-            <a:schemeClr val="accent1"/>
-          </a:effectRef>
-          <a:fontRef idx="minor">
-            <a:schemeClr val="lt1"/>
-          </a:fontRef>
-        </p:style>
-        <p:txBody>
-          <a:bodyPr rtlCol="0" anchor="ctr" wrap="square"/>
-          <a:lstStyle/>
-          <a:p>
-            <a:pPr algn="ctr">
-              <a:defRPr sz="1400" b="1">
-                <a:solidFill>
-                  <a:srgbClr val="3B82F6"/>
-                </a:solidFill>
-              </a:defRPr>
-            </a:pPr>
-            <a:r>
-              <a:t>Serverless Lambda</a:t>
-            </a:r>
-          </a:p>
-          <a:p>
-            <a:pPr>
-              <a:defRPr sz="900" b="1">
-                <a:solidFill>
-                  <a:srgbClr val="94A3B8"/>
-                </a:solidFill>
-              </a:defRPr>
-            </a:pPr>
-            <a:r>
-              <a:t>EVENT-DRIVEN PROCESSING</a:t>
-            </a:r>
-          </a:p>
-          <a:p>
-            <a:br/>
-            <a:pPr>
-              <a:defRPr sz="1050">
-                <a:solidFill>
-                  <a:srgbClr val="F1F5F9"/>
-                </a:solidFill>
-              </a:defRPr>
-            </a:pPr>
-            <a:r>
-              <a:t>Consumes SQS batches, updates fulfillment states, and calculates inventory safety stock deductions.</a:t>
+              <a:t>SC-COLD-CHAIN-SLA automatically monitors IoT sensor beacons. Temperature excursions (&gt;8°C) freeze escrow funds and log breach infractions immutably.</a:t>
             </a:r>
           </a:p>
         </p:txBody>
@@ -4571,7 +4299,7 @@
               </a:defRPr>
             </a:pPr>
             <a:r>
-              <a:t>AWS CLOUD SUPPLY CHAIN PLATFORM</a:t>
+              <a:t>AWS CLOUD &amp; BLOCKCHAIN PLATFORM</a:t>
             </a:r>
           </a:p>
         </p:txBody>
@@ -4606,7 +4334,7 @@
               </a:defRPr>
             </a:pPr>
             <a:r>
-              <a:t>Core Functional Modules in the SCM Control Tower</a:t>
+              <a:t>Enterprise AWS Cloud Architecture Mappings</a:t>
             </a:r>
           </a:p>
         </p:txBody>
@@ -4620,7 +4348,7 @@
         <p:spPr>
           <a:xfrm>
             <a:off x="731520" y="1554480"/>
-            <a:ext cx="5212080" cy="2240280"/>
+            <a:ext cx="3383280" cy="2194560"/>
           </a:xfrm>
           <a:prstGeom prst="roundRect">
             <a:avLst/>
@@ -4628,8 +4356,10 @@
           <a:solidFill>
             <a:srgbClr val="1A2438"/>
           </a:solidFill>
-          <a:ln>
-            <a:noFill/>
+          <a:ln w="19050">
+            <a:solidFill>
+              <a:srgbClr val="FF9900"/>
+            </a:solidFill>
           </a:ln>
         </p:spPr>
         <p:style>
@@ -4658,10 +4388,23 @@
               </a:defRPr>
             </a:pPr>
             <a:r>
-              <a:t>1. Multi-Hub Warehouse (WMS)</a:t>
-            </a:r>
-          </a:p>
-          <a:p>
+              <a:t>Amazon DynamoDB</a:t>
+            </a:r>
+          </a:p>
+          <a:p>
+            <a:pPr>
+              <a:defRPr sz="900" b="1">
+                <a:solidFill>
+                  <a:srgbClr val="94A3B8"/>
+                </a:solidFill>
+              </a:defRPr>
+            </a:pPr>
+            <a:r>
+              <a:t>NOSQL OPERATIONAL STORE</a:t>
+            </a:r>
+          </a:p>
+          <a:p>
+            <a:br/>
             <a:pPr>
               <a:defRPr sz="1050">
                 <a:solidFill>
@@ -4670,31 +4413,7 @@
               </a:defRPr>
             </a:pPr>
             <a:r>
-              <a:t>• Real-time stock ledger across Chicago, Boston, and Frankfurt facilities</a:t>
-            </a:r>
-          </a:p>
-          <a:p>
-            <a:pPr>
-              <a:defRPr sz="1050">
-                <a:solidFill>
-                  <a:srgbClr val="F1F5F9"/>
-                </a:solidFill>
-              </a:defRPr>
-            </a:pPr>
-            <a:r>
-              <a:t>• Automatic safety stock calculations and low-inventory warnings</a:t>
-            </a:r>
-          </a:p>
-          <a:p>
-            <a:pPr>
-              <a:defRPr sz="1050">
-                <a:solidFill>
-                  <a:srgbClr val="F1F5F9"/>
-                </a:solidFill>
-              </a:defRPr>
-            </a:pPr>
-            <a:r>
-              <a:t>• Storage categorization (Ultra-Cold, ESD Cleanroom, Ambient)</a:t>
+              <a:t>Low-latency schema for Warehouses, Orders, Shipments, and Time-series Telemetry with automated 30-day TTL.</a:t>
             </a:r>
           </a:p>
         </p:txBody>
@@ -4707,8 +4426,8 @@
         </p:nvSpPr>
         <p:spPr>
           <a:xfrm>
-            <a:off x="6172200" y="1554480"/>
-            <a:ext cx="5212080" cy="2240280"/>
+            <a:off x="4343400" y="1554480"/>
+            <a:ext cx="3383280" cy="2194560"/>
           </a:xfrm>
           <a:prstGeom prst="roundRect">
             <a:avLst/>
@@ -4716,8 +4435,10 @@
           <a:solidFill>
             <a:srgbClr val="1A2438"/>
           </a:solidFill>
-          <a:ln>
-            <a:noFill/>
+          <a:ln w="19050">
+            <a:solidFill>
+              <a:srgbClr val="22D3EE"/>
+            </a:solidFill>
           </a:ln>
         </p:spPr>
         <p:style>
@@ -4741,15 +4462,28 @@
             <a:pPr algn="ctr">
               <a:defRPr sz="1400" b="1">
                 <a:solidFill>
-                  <a:srgbClr val="FF9900"/>
-                </a:solidFill>
-              </a:defRPr>
-            </a:pPr>
-            <a:r>
-              <a:t>2. Asynchronous Order Pipeline (OMS)</a:t>
-            </a:r>
-          </a:p>
-          <a:p>
+                  <a:srgbClr val="22D3EE"/>
+                </a:solidFill>
+              </a:defRPr>
+            </a:pPr>
+            <a:r>
+              <a:t>Amazon SQS</a:t>
+            </a:r>
+          </a:p>
+          <a:p>
+            <a:pPr>
+              <a:defRPr sz="900" b="1">
+                <a:solidFill>
+                  <a:srgbClr val="94A3B8"/>
+                </a:solidFill>
+              </a:defRPr>
+            </a:pPr>
+            <a:r>
+              <a:t>DECOUPLED ORDER QUEUE</a:t>
+            </a:r>
+          </a:p>
+          <a:p>
+            <a:br/>
             <a:pPr>
               <a:defRPr sz="1050">
                 <a:solidFill>
@@ -4758,31 +4492,7 @@
               </a:defRPr>
             </a:pPr>
             <a:r>
-              <a:t>• Customer orders queued directly to Amazon SQS</a:t>
-            </a:r>
-          </a:p>
-          <a:p>
-            <a:pPr>
-              <a:defRPr sz="1050">
-                <a:solidFill>
-                  <a:srgbClr val="F1F5F9"/>
-                </a:solidFill>
-              </a:defRPr>
-            </a:pPr>
-            <a:r>
-              <a:t>• Fulfillment worker polling and state updates: QUEUED ➔ PROCESSING ➔ DISPATCHED</a:t>
-            </a:r>
-          </a:p>
-          <a:p>
-            <a:pPr>
-              <a:defRPr sz="1050">
-                <a:solidFill>
-                  <a:srgbClr val="F1F5F9"/>
-                </a:solidFill>
-              </a:defRPr>
-            </a:pPr>
-            <a:r>
-              <a:t>• Automated generation of digital PDF/JSON invoices archived to S3</a:t>
+              <a:t>Buffers incoming customer orders. Employs Dead-Letter Queue (DLQ) with maxReceiveCount=3 to isolate poison messages.</a:t>
             </a:r>
           </a:p>
         </p:txBody>
@@ -4795,8 +4505,8 @@
         </p:nvSpPr>
         <p:spPr>
           <a:xfrm>
-            <a:off x="731520" y="3977639"/>
-            <a:ext cx="5212080" cy="2240280"/>
+            <a:off x="7955280" y="1554480"/>
+            <a:ext cx="3383280" cy="2194560"/>
           </a:xfrm>
           <a:prstGeom prst="roundRect">
             <a:avLst/>
@@ -4804,8 +4514,10 @@
           <a:solidFill>
             <a:srgbClr val="1A2438"/>
           </a:solidFill>
-          <a:ln>
-            <a:noFill/>
+          <a:ln w="19050">
+            <a:solidFill>
+              <a:srgbClr val="F59E0B"/>
+            </a:solidFill>
           </a:ln>
         </p:spPr>
         <p:style>
@@ -4829,15 +4541,28 @@
             <a:pPr algn="ctr">
               <a:defRPr sz="1400" b="1">
                 <a:solidFill>
-                  <a:srgbClr val="FF9900"/>
-                </a:solidFill>
-              </a:defRPr>
-            </a:pPr>
-            <a:r>
-              <a:t>3. Fleet Logistics &amp; IoT Tracking (TMS)</a:t>
-            </a:r>
-          </a:p>
-          <a:p>
+                  <a:srgbClr val="F59E0B"/>
+                </a:solidFill>
+              </a:defRPr>
+            </a:pPr>
+            <a:r>
+              <a:t>Amazon SNS</a:t>
+            </a:r>
+          </a:p>
+          <a:p>
+            <a:pPr>
+              <a:defRPr sz="900" b="1">
+                <a:solidFill>
+                  <a:srgbClr val="94A3B8"/>
+                </a:solidFill>
+              </a:defRPr>
+            </a:pPr>
+            <a:r>
+              <a:t>PUB/SUB BROADCAST TOPIC</a:t>
+            </a:r>
+          </a:p>
+          <a:p>
+            <a:br/>
             <a:pPr>
               <a:defRPr sz="1050">
                 <a:solidFill>
@@ -4846,31 +4571,7 @@
               </a:defRPr>
             </a:pPr>
             <a:r>
-              <a:t>• Highway route simulation with live waypoint updates</a:t>
-            </a:r>
-          </a:p>
-          <a:p>
-            <a:pPr>
-              <a:defRPr sz="1050">
-                <a:solidFill>
-                  <a:srgbClr val="F1F5F9"/>
-                </a:solidFill>
-              </a:defRPr>
-            </a:pPr>
-            <a:r>
-              <a:t>• Environmental sensors: Temperature (°C), Humidity (%), Shock (G), Battery (%)</a:t>
-            </a:r>
-          </a:p>
-          <a:p>
-            <a:pPr>
-              <a:defRPr sz="1050">
-                <a:solidFill>
-                  <a:srgbClr val="F1F5F9"/>
-                </a:solidFill>
-              </a:defRPr>
-            </a:pPr>
-            <a:r>
-              <a:t>• Automated threshold evaluation triggering instant SMS/Email via SNS</a:t>
+              <a:t>Dispatches instant alerts for temperature violations (&gt;8°C), road shock damage, and inventory reorder point breaches.</a:t>
             </a:r>
           </a:p>
         </p:txBody>
@@ -4883,8 +4584,8 @@
         </p:nvSpPr>
         <p:spPr>
           <a:xfrm>
-            <a:off x="6172200" y="3977639"/>
-            <a:ext cx="5212080" cy="2240280"/>
+            <a:off x="731520" y="3977639"/>
+            <a:ext cx="3383280" cy="2194560"/>
           </a:xfrm>
           <a:prstGeom prst="roundRect">
             <a:avLst/>
@@ -4892,8 +4593,10 @@
           <a:solidFill>
             <a:srgbClr val="1A2438"/>
           </a:solidFill>
-          <a:ln>
-            <a:noFill/>
+          <a:ln w="19050">
+            <a:solidFill>
+              <a:srgbClr val="34D399"/>
+            </a:solidFill>
           </a:ln>
         </p:spPr>
         <p:style>
@@ -4917,15 +4620,28 @@
             <a:pPr algn="ctr">
               <a:defRPr sz="1400" b="1">
                 <a:solidFill>
-                  <a:srgbClr val="FF9900"/>
-                </a:solidFill>
-              </a:defRPr>
-            </a:pPr>
-            <a:r>
-              <a:t>4. Supplier Procurement (SRM)</a:t>
-            </a:r>
-          </a:p>
-          <a:p>
+                  <a:srgbClr val="34D399"/>
+                </a:solidFill>
+              </a:defRPr>
+            </a:pPr>
+            <a:r>
+              <a:t>Amazon S3</a:t>
+            </a:r>
+          </a:p>
+          <a:p>
+            <a:pPr>
+              <a:defRPr sz="900" b="1">
+                <a:solidFill>
+                  <a:srgbClr val="94A3B8"/>
+                </a:solidFill>
+              </a:defRPr>
+            </a:pPr>
+            <a:r>
+              <a:t>SECURE DOCUMENT LAKE</a:t>
+            </a:r>
+          </a:p>
+          <a:p>
+            <a:br/>
             <a:pPr>
               <a:defRPr sz="1050">
                 <a:solidFill>
@@ -4934,10 +4650,77 @@
               </a:defRPr>
             </a:pPr>
             <a:r>
-              <a:t>• Comprehensive vendor master database with reliability rates (98%+)</a:t>
-            </a:r>
-          </a:p>
-          <a:p>
+              <a:t>Stores immutable digital invoices, bills of lading, and delivery signatures with AES-256 encryption and versioning.</a:t>
+            </a:r>
+          </a:p>
+        </p:txBody>
+      </p:sp>
+      <p:sp>
+        <p:nvSpPr>
+          <p:cNvPr id="9" name="Rounded Rectangle 8"/>
+          <p:cNvSpPr/>
+          <p:nvPr/>
+        </p:nvSpPr>
+        <p:spPr>
+          <a:xfrm>
+            <a:off x="4343400" y="3977639"/>
+            <a:ext cx="3383280" cy="2194560"/>
+          </a:xfrm>
+          <a:prstGeom prst="roundRect">
+            <a:avLst/>
+          </a:prstGeom>
+          <a:solidFill>
+            <a:srgbClr val="1A2438"/>
+          </a:solidFill>
+          <a:ln w="19050">
+            <a:solidFill>
+              <a:srgbClr val="A855F7"/>
+            </a:solidFill>
+          </a:ln>
+        </p:spPr>
+        <p:style>
+          <a:lnRef idx="1">
+            <a:schemeClr val="accent1"/>
+          </a:lnRef>
+          <a:fillRef idx="3">
+            <a:schemeClr val="accent1"/>
+          </a:fillRef>
+          <a:effectRef idx="2">
+            <a:schemeClr val="accent1"/>
+          </a:effectRef>
+          <a:fontRef idx="minor">
+            <a:schemeClr val="lt1"/>
+          </a:fontRef>
+        </p:style>
+        <p:txBody>
+          <a:bodyPr rtlCol="0" anchor="ctr" wrap="square"/>
+          <a:lstStyle/>
+          <a:p>
+            <a:pPr algn="ctr">
+              <a:defRPr sz="1400" b="1">
+                <a:solidFill>
+                  <a:srgbClr val="A855F7"/>
+                </a:solidFill>
+              </a:defRPr>
+            </a:pPr>
+            <a:r>
+              <a:t>AWS IoT Core</a:t>
+            </a:r>
+          </a:p>
+          <a:p>
+            <a:pPr>
+              <a:defRPr sz="900" b="1">
+                <a:solidFill>
+                  <a:srgbClr val="94A3B8"/>
+                </a:solidFill>
+              </a:defRPr>
+            </a:pPr>
+            <a:r>
+              <a:t>TELEMETRY RULES ENGINE</a:t>
+            </a:r>
+          </a:p>
+          <a:p>
+            <a:br/>
             <a:pPr>
               <a:defRPr sz="1050">
                 <a:solidFill>
@@ -4946,10 +4729,77 @@
               </a:defRPr>
             </a:pPr>
             <a:r>
-              <a:t>• Lead time monitoring (days) and purchase contract management</a:t>
-            </a:r>
-          </a:p>
-          <a:p>
+              <a:t>Ingests live vehicle sensor metrics (temp, humidity, shock, GPS, battery) and forwards directly to DynamoDB &amp; Blockchain.</a:t>
+            </a:r>
+          </a:p>
+        </p:txBody>
+      </p:sp>
+      <p:sp>
+        <p:nvSpPr>
+          <p:cNvPr id="10" name="Rounded Rectangle 9"/>
+          <p:cNvSpPr/>
+          <p:nvPr/>
+        </p:nvSpPr>
+        <p:spPr>
+          <a:xfrm>
+            <a:off x="7955280" y="3977639"/>
+            <a:ext cx="3383280" cy="2194560"/>
+          </a:xfrm>
+          <a:prstGeom prst="roundRect">
+            <a:avLst/>
+          </a:prstGeom>
+          <a:solidFill>
+            <a:srgbClr val="1A2438"/>
+          </a:solidFill>
+          <a:ln w="19050">
+            <a:solidFill>
+              <a:srgbClr val="3B82F6"/>
+            </a:solidFill>
+          </a:ln>
+        </p:spPr>
+        <p:style>
+          <a:lnRef idx="1">
+            <a:schemeClr val="accent1"/>
+          </a:lnRef>
+          <a:fillRef idx="3">
+            <a:schemeClr val="accent1"/>
+          </a:fillRef>
+          <a:effectRef idx="2">
+            <a:schemeClr val="accent1"/>
+          </a:effectRef>
+          <a:fontRef idx="minor">
+            <a:schemeClr val="lt1"/>
+          </a:fontRef>
+        </p:style>
+        <p:txBody>
+          <a:bodyPr rtlCol="0" anchor="ctr" wrap="square"/>
+          <a:lstStyle/>
+          <a:p>
+            <a:pPr algn="ctr">
+              <a:defRPr sz="1400" b="1">
+                <a:solidFill>
+                  <a:srgbClr val="3B82F6"/>
+                </a:solidFill>
+              </a:defRPr>
+            </a:pPr>
+            <a:r>
+              <a:t>Serverless Workers</a:t>
+            </a:r>
+          </a:p>
+          <a:p>
+            <a:pPr>
+              <a:defRPr sz="900" b="1">
+                <a:solidFill>
+                  <a:srgbClr val="94A3B8"/>
+                </a:solidFill>
+              </a:defRPr>
+            </a:pPr>
+            <a:r>
+              <a:t>EVENT-DRIVEN PROCESSING</a:t>
+            </a:r>
+          </a:p>
+          <a:p>
+            <a:br/>
             <a:pPr>
               <a:defRPr sz="1050">
                 <a:solidFill>
@@ -4958,7 +4808,7 @@
               </a:defRPr>
             </a:pPr>
             <a:r>
-              <a:t>• Verified vendor performance ratings and compliance status</a:t>
+              <a:t>Consumes SQS batches, updates fulfillment states, and calculates inventory safety stock deductions.</a:t>
             </a:r>
           </a:p>
         </p:txBody>
@@ -5054,7 +4904,7 @@
               </a:defRPr>
             </a:pPr>
             <a:r>
-              <a:t>INFRASTRUCTURE AS CODE &amp; GOVERNANCE</a:t>
+              <a:t>AWS CLOUD &amp; BLOCKCHAIN PLATFORM</a:t>
             </a:r>
           </a:p>
         </p:txBody>
@@ -5089,7 +4939,7 @@
               </a:defRPr>
             </a:pPr>
             <a:r>
-              <a:t>Cloud Security, Privacy &amp; Terraform Infrastructure as Code</a:t>
+              <a:t>Core Functional Modules in the SCM Control Tower</a:t>
             </a:r>
           </a:p>
         </p:txBody>
@@ -5102,74 +4952,8 @@
         </p:nvSpPr>
         <p:spPr>
           <a:xfrm>
-            <a:off x="731520" y="1463040"/>
-            <a:ext cx="10698480" cy="1188720"/>
-          </a:xfrm>
-          <a:prstGeom prst="roundRect">
-            <a:avLst/>
-          </a:prstGeom>
-          <a:solidFill>
-            <a:srgbClr val="1A2438"/>
-          </a:solidFill>
-          <a:ln>
-            <a:solidFill>
-              <a:srgbClr val="FF9900"/>
-            </a:solidFill>
-          </a:ln>
-        </p:spPr>
-        <p:style>
-          <a:lnRef idx="1">
-            <a:schemeClr val="accent1"/>
-          </a:lnRef>
-          <a:fillRef idx="3">
-            <a:schemeClr val="accent1"/>
-          </a:fillRef>
-          <a:effectRef idx="2">
-            <a:schemeClr val="accent1"/>
-          </a:effectRef>
-          <a:fontRef idx="minor">
-            <a:schemeClr val="lt1"/>
-          </a:fontRef>
-        </p:style>
-        <p:txBody>
-          <a:bodyPr rtlCol="0" anchor="ctr" wrap="square"/>
-          <a:lstStyle/>
-          <a:p>
-            <a:pPr algn="ctr">
-              <a:defRPr sz="1300" b="1">
-                <a:solidFill>
-                  <a:srgbClr val="FF9900"/>
-                </a:solidFill>
-              </a:defRPr>
-            </a:pPr>
-            <a:r>
-              <a:t>🔒 Does Terraform Code &amp; Deployment Commands Need to Be Private?</a:t>
-            </a:r>
-          </a:p>
-          <a:p>
-            <a:pPr>
-              <a:defRPr sz="1100">
-                <a:solidFill>
-                  <a:srgbClr val="F1F5F9"/>
-                </a:solidFill>
-              </a:defRPr>
-            </a:pPr>
-            <a:r>
-              <a:t>NO. Declarative Terraform resource definitions (HCL) and CLI instructions (terraform apply) are public architectural blueprints. What MUST be private are credentials, secret keys, and runtime state files — all of which are strictly isolated.</a:t>
-            </a:r>
-          </a:p>
-        </p:txBody>
-      </p:sp>
-      <p:sp>
-        <p:nvSpPr>
-          <p:cNvPr id="6" name="Rounded Rectangle 5"/>
-          <p:cNvSpPr/>
-          <p:nvPr/>
-        </p:nvSpPr>
-        <p:spPr>
-          <a:xfrm>
-            <a:off x="731520" y="2834640"/>
-            <a:ext cx="3383280" cy="3474720"/>
+            <a:off x="731520" y="1554480"/>
+            <a:ext cx="5212080" cy="2240280"/>
           </a:xfrm>
           <a:prstGeom prst="roundRect">
             <a:avLst/>
@@ -5200,67 +4984,64 @@
           <a:lstStyle/>
           <a:p>
             <a:pPr algn="ctr">
-              <a:defRPr sz="1300" b="1">
-                <a:solidFill>
-                  <a:srgbClr val="22D3EE"/>
-                </a:solidFill>
-              </a:defRPr>
-            </a:pPr>
-            <a:r>
-              <a:t>1. Strict Secret Protection</a:t>
-            </a:r>
-          </a:p>
-          <a:p>
-            <a:br/>
-            <a:pPr>
-              <a:defRPr sz="1100">
+              <a:defRPr sz="1400" b="1">
+                <a:solidFill>
+                  <a:srgbClr val="FF9900"/>
+                </a:solidFill>
+              </a:defRPr>
+            </a:pPr>
+            <a:r>
+              <a:t>1. Multi-Hub Warehouse (WMS)</a:t>
+            </a:r>
+          </a:p>
+          <a:p>
+            <a:pPr>
+              <a:defRPr sz="1050">
                 <a:solidFill>
                   <a:srgbClr val="F1F5F9"/>
                 </a:solidFill>
               </a:defRPr>
             </a:pPr>
             <a:r>
-              <a:t>• .gitignore isolates all .env, *.tfstate, and *.tfvars files</a:t>
-            </a:r>
-          </a:p>
-          <a:p>
-            <a:br/>
-            <a:pPr>
-              <a:defRPr sz="1100">
+              <a:t>• Real-time stock ledger across Chicago, Boston, and Frankfurt facilities</a:t>
+            </a:r>
+          </a:p>
+          <a:p>
+            <a:pPr>
+              <a:defRPr sz="1050">
                 <a:solidFill>
                   <a:srgbClr val="F1F5F9"/>
                 </a:solidFill>
               </a:defRPr>
             </a:pPr>
             <a:r>
-              <a:t>• Zero AWS Access Keys or secrets hardcoded in Git</a:t>
-            </a:r>
-          </a:p>
-          <a:p>
-            <a:br/>
-            <a:pPr>
-              <a:defRPr sz="1100">
+              <a:t>• Automatic safety stock calculations and low-inventory warnings</a:t>
+            </a:r>
+          </a:p>
+          <a:p>
+            <a:pPr>
+              <a:defRPr sz="1050">
                 <a:solidFill>
                   <a:srgbClr val="F1F5F9"/>
                 </a:solidFill>
               </a:defRPr>
             </a:pPr>
             <a:r>
-              <a:t>• Anyone running code uses their own local AWS profile credentials</a:t>
-            </a:r>
-          </a:p>
-        </p:txBody>
-      </p:sp>
-      <p:sp>
-        <p:nvSpPr>
-          <p:cNvPr id="7" name="Rounded Rectangle 6"/>
+              <a:t>• Storage categorization (Ultra-Cold, ESD Cleanroom, Ambient)</a:t>
+            </a:r>
+          </a:p>
+        </p:txBody>
+      </p:sp>
+      <p:sp>
+        <p:nvSpPr>
+          <p:cNvPr id="6" name="Rounded Rectangle 5"/>
           <p:cNvSpPr/>
           <p:nvPr/>
         </p:nvSpPr>
         <p:spPr>
           <a:xfrm>
-            <a:off x="4343400" y="2834640"/>
-            <a:ext cx="3383280" cy="3474720"/>
+            <a:off x="6172200" y="1554480"/>
+            <a:ext cx="5212080" cy="2240280"/>
           </a:xfrm>
           <a:prstGeom prst="roundRect">
             <a:avLst/>
@@ -5291,67 +5072,64 @@
           <a:lstStyle/>
           <a:p>
             <a:pPr algn="ctr">
-              <a:defRPr sz="1300" b="1">
-                <a:solidFill>
-                  <a:srgbClr val="22D3EE"/>
-                </a:solidFill>
-              </a:defRPr>
-            </a:pPr>
-            <a:r>
-              <a:t>2. Least-Privilege IAM</a:t>
-            </a:r>
-          </a:p>
-          <a:p>
-            <a:br/>
-            <a:pPr>
-              <a:defRPr sz="1100">
+              <a:defRPr sz="1400" b="1">
+                <a:solidFill>
+                  <a:srgbClr val="FF9900"/>
+                </a:solidFill>
+              </a:defRPr>
+            </a:pPr>
+            <a:r>
+              <a:t>2. Asynchronous Order Pipeline (OMS)</a:t>
+            </a:r>
+          </a:p>
+          <a:p>
+            <a:pPr>
+              <a:defRPr sz="1050">
                 <a:solidFill>
                   <a:srgbClr val="F1F5F9"/>
                 </a:solidFill>
               </a:defRPr>
             </a:pPr>
             <a:r>
-              <a:t>• Lambda execution roles scoped strictly to specific SQS &amp; DynamoDB ARNs</a:t>
-            </a:r>
-          </a:p>
-          <a:p>
-            <a:br/>
-            <a:pPr>
-              <a:defRPr sz="1100">
+              <a:t>• Customer orders queued directly to Amazon SQS</a:t>
+            </a:r>
+          </a:p>
+          <a:p>
+            <a:pPr>
+              <a:defRPr sz="1050">
                 <a:solidFill>
                   <a:srgbClr val="F1F5F9"/>
                 </a:solidFill>
               </a:defRPr>
             </a:pPr>
             <a:r>
-              <a:t>• S3 Bucket Public Access Block enabled to prevent data exposure</a:t>
-            </a:r>
-          </a:p>
-          <a:p>
-            <a:br/>
-            <a:pPr>
-              <a:defRPr sz="1100">
+              <a:t>• Fulfillment worker polling: QUEUED ➔ PROCESSING ➔ DISPATCHED</a:t>
+            </a:r>
+          </a:p>
+          <a:p>
+            <a:pPr>
+              <a:defRPr sz="1050">
                 <a:solidFill>
                   <a:srgbClr val="F1F5F9"/>
                 </a:solidFill>
               </a:defRPr>
             </a:pPr>
             <a:r>
-              <a:t>• Server-side encryption enabled by default (SSE-S3 AES-256)</a:t>
-            </a:r>
-          </a:p>
-        </p:txBody>
-      </p:sp>
-      <p:sp>
-        <p:nvSpPr>
-          <p:cNvPr id="8" name="Rounded Rectangle 7"/>
+              <a:t>• Automated generation of digital PDF/JSON invoices archived to S3</a:t>
+            </a:r>
+          </a:p>
+        </p:txBody>
+      </p:sp>
+      <p:sp>
+        <p:nvSpPr>
+          <p:cNvPr id="7" name="Rounded Rectangle 6"/>
           <p:cNvSpPr/>
           <p:nvPr/>
         </p:nvSpPr>
         <p:spPr>
           <a:xfrm>
-            <a:off x="7955280" y="2834640"/>
-            <a:ext cx="3383280" cy="3474720"/>
+            <a:off x="731520" y="3977639"/>
+            <a:ext cx="5212080" cy="2240280"/>
           </a:xfrm>
           <a:prstGeom prst="roundRect">
             <a:avLst/>
@@ -5382,53 +5160,138 @@
           <a:lstStyle/>
           <a:p>
             <a:pPr algn="ctr">
-              <a:defRPr sz="1300" b="1">
-                <a:solidFill>
-                  <a:srgbClr val="22D3EE"/>
-                </a:solidFill>
-              </a:defRPr>
-            </a:pPr>
-            <a:r>
-              <a:t>3. Automated CI/CD</a:t>
-            </a:r>
-          </a:p>
-          <a:p>
-            <a:br/>
-            <a:pPr>
-              <a:defRPr sz="1100">
+              <a:defRPr sz="1400" b="1">
+                <a:solidFill>
+                  <a:srgbClr val="FF9900"/>
+                </a:solidFill>
+              </a:defRPr>
+            </a:pPr>
+            <a:r>
+              <a:t>3. Fleet Logistics &amp; IoT Tracking (TMS)</a:t>
+            </a:r>
+          </a:p>
+          <a:p>
+            <a:pPr>
+              <a:defRPr sz="1050">
                 <a:solidFill>
                   <a:srgbClr val="F1F5F9"/>
                 </a:solidFill>
               </a:defRPr>
             </a:pPr>
             <a:r>
-              <a:t>• GitHub Actions runs terraform fmt &amp; syntax validation on every push</a:t>
-            </a:r>
-          </a:p>
-          <a:p>
-            <a:br/>
-            <a:pPr>
-              <a:defRPr sz="1100">
+              <a:t>• Highway route simulation with live waypoint updates</a:t>
+            </a:r>
+          </a:p>
+          <a:p>
+            <a:pPr>
+              <a:defRPr sz="1050">
                 <a:solidFill>
                   <a:srgbClr val="F1F5F9"/>
                 </a:solidFill>
               </a:defRPr>
             </a:pPr>
             <a:r>
-              <a:t>• Automated builds for both backend API and React frontend</a:t>
-            </a:r>
-          </a:p>
-          <a:p>
-            <a:br/>
-            <a:pPr>
-              <a:defRPr sz="1100">
+              <a:t>• Environmental sensors: Temperature (°C), Humidity (%), Shock (G), Battery (%)</a:t>
+            </a:r>
+          </a:p>
+          <a:p>
+            <a:pPr>
+              <a:defRPr sz="1050">
                 <a:solidFill>
                   <a:srgbClr val="F1F5F9"/>
                 </a:solidFill>
               </a:defRPr>
             </a:pPr>
             <a:r>
-              <a:t>• Zero-downtime static deployment to GitHub Pages CDN</a:t>
+              <a:t>• Automated threshold evaluation triggering instant SMS/Email via SNS</a:t>
+            </a:r>
+          </a:p>
+        </p:txBody>
+      </p:sp>
+      <p:sp>
+        <p:nvSpPr>
+          <p:cNvPr id="8" name="Rounded Rectangle 7"/>
+          <p:cNvSpPr/>
+          <p:nvPr/>
+        </p:nvSpPr>
+        <p:spPr>
+          <a:xfrm>
+            <a:off x="6172200" y="3977639"/>
+            <a:ext cx="5212080" cy="2240280"/>
+          </a:xfrm>
+          <a:prstGeom prst="roundRect">
+            <a:avLst/>
+          </a:prstGeom>
+          <a:solidFill>
+            <a:srgbClr val="1A2438"/>
+          </a:solidFill>
+          <a:ln>
+            <a:noFill/>
+          </a:ln>
+        </p:spPr>
+        <p:style>
+          <a:lnRef idx="1">
+            <a:schemeClr val="accent1"/>
+          </a:lnRef>
+          <a:fillRef idx="3">
+            <a:schemeClr val="accent1"/>
+          </a:fillRef>
+          <a:effectRef idx="2">
+            <a:schemeClr val="accent1"/>
+          </a:effectRef>
+          <a:fontRef idx="minor">
+            <a:schemeClr val="lt1"/>
+          </a:fontRef>
+        </p:style>
+        <p:txBody>
+          <a:bodyPr rtlCol="0" anchor="ctr" wrap="square"/>
+          <a:lstStyle/>
+          <a:p>
+            <a:pPr algn="ctr">
+              <a:defRPr sz="1400" b="1">
+                <a:solidFill>
+                  <a:srgbClr val="FF9900"/>
+                </a:solidFill>
+              </a:defRPr>
+            </a:pPr>
+            <a:r>
+              <a:t>4. Blockchain Explorer &amp; Smart Contracts</a:t>
+            </a:r>
+          </a:p>
+          <a:p>
+            <a:pPr>
+              <a:defRPr sz="1050">
+                <a:solidFill>
+                  <a:srgbClr val="F1F5F9"/>
+                </a:solidFill>
+              </a:defRPr>
+            </a:pPr>
+            <a:r>
+              <a:t>• Visual chronological Merkle chain with SHA-256 block inspection</a:t>
+            </a:r>
+          </a:p>
+          <a:p>
+            <a:pPr>
+              <a:defRPr sz="1050">
+                <a:solidFill>
+                  <a:srgbClr val="F1F5F9"/>
+                </a:solidFill>
+              </a:defRPr>
+            </a:pPr>
+            <a:r>
+              <a:t>• Digital custody handover signing between carriers and depots</a:t>
+            </a:r>
+          </a:p>
+          <a:p>
+            <a:pPr>
+              <a:defRPr sz="1050">
+                <a:solidFill>
+                  <a:srgbClr val="F1F5F9"/>
+                </a:solidFill>
+              </a:defRPr>
+            </a:pPr>
+            <a:r>
+              <a:t>• Cold-chain escrow contract monitoring with automated penalty enforcement</a:t>
             </a:r>
           </a:p>
         </p:txBody>
@@ -5524,7 +5387,7 @@
               </a:defRPr>
             </a:pPr>
             <a:r>
-              <a:t>RESULTS &amp; HORIZONS</a:t>
+              <a:t>INFRASTRUCTURE AS CODE &amp; GOVERNANCE</a:t>
             </a:r>
           </a:p>
         </p:txBody>
@@ -5559,7 +5422,7 @@
               </a:defRPr>
             </a:pPr>
             <a:r>
-              <a:t>Project Deliverables, Live Demo &amp; Future Roadmap</a:t>
+              <a:t>Cloud Security, Privacy &amp; Terraform Infrastructure as Code</a:t>
             </a:r>
           </a:p>
         </p:txBody>
@@ -5572,8 +5435,74 @@
         </p:nvSpPr>
         <p:spPr>
           <a:xfrm>
-            <a:off x="731520" y="1554480"/>
-            <a:ext cx="5120640" cy="4754880"/>
+            <a:off x="731520" y="1463040"/>
+            <a:ext cx="10698480" cy="1188720"/>
+          </a:xfrm>
+          <a:prstGeom prst="roundRect">
+            <a:avLst/>
+          </a:prstGeom>
+          <a:solidFill>
+            <a:srgbClr val="1A2438"/>
+          </a:solidFill>
+          <a:ln>
+            <a:solidFill>
+              <a:srgbClr val="FF9900"/>
+            </a:solidFill>
+          </a:ln>
+        </p:spPr>
+        <p:style>
+          <a:lnRef idx="1">
+            <a:schemeClr val="accent1"/>
+          </a:lnRef>
+          <a:fillRef idx="3">
+            <a:schemeClr val="accent1"/>
+          </a:fillRef>
+          <a:effectRef idx="2">
+            <a:schemeClr val="accent1"/>
+          </a:effectRef>
+          <a:fontRef idx="minor">
+            <a:schemeClr val="lt1"/>
+          </a:fontRef>
+        </p:style>
+        <p:txBody>
+          <a:bodyPr rtlCol="0" anchor="ctr" wrap="square"/>
+          <a:lstStyle/>
+          <a:p>
+            <a:pPr algn="ctr">
+              <a:defRPr sz="1300" b="1">
+                <a:solidFill>
+                  <a:srgbClr val="FF9900"/>
+                </a:solidFill>
+              </a:defRPr>
+            </a:pPr>
+            <a:r>
+              <a:t>🔒 Does Terraform Code &amp; Deployment Commands Need to Be Private?</a:t>
+            </a:r>
+          </a:p>
+          <a:p>
+            <a:pPr>
+              <a:defRPr sz="1100">
+                <a:solidFill>
+                  <a:srgbClr val="F1F5F9"/>
+                </a:solidFill>
+              </a:defRPr>
+            </a:pPr>
+            <a:r>
+              <a:t>NO. Declarative Terraform resource definitions (HCL) and CLI instructions (terraform apply) are public architectural blueprints. What MUST be private are credentials, secret keys, and runtime state files — all of which are strictly isolated.</a:t>
+            </a:r>
+          </a:p>
+        </p:txBody>
+      </p:sp>
+      <p:sp>
+        <p:nvSpPr>
+          <p:cNvPr id="6" name="Rounded Rectangle 5"/>
+          <p:cNvSpPr/>
+          <p:nvPr/>
+        </p:nvSpPr>
+        <p:spPr>
+          <a:xfrm>
+            <a:off x="731520" y="2834640"/>
+            <a:ext cx="3383280" cy="3474720"/>
           </a:xfrm>
           <a:prstGeom prst="roundRect">
             <a:avLst/>
@@ -5604,153 +5533,67 @@
           <a:lstStyle/>
           <a:p>
             <a:pPr algn="ctr">
-              <a:defRPr sz="1500" b="1">
-                <a:solidFill>
-                  <a:srgbClr val="34D399"/>
-                </a:solidFill>
-              </a:defRPr>
-            </a:pPr>
-            <a:r>
-              <a:t>📈 Key Engineering Deliverables</a:t>
+              <a:defRPr sz="1300" b="1">
+                <a:solidFill>
+                  <a:srgbClr val="22D3EE"/>
+                </a:solidFill>
+              </a:defRPr>
+            </a:pPr>
+            <a:r>
+              <a:t>1. Strict Secret Protection</a:t>
             </a:r>
           </a:p>
           <a:p>
             <a:br/>
             <a:pPr>
-              <a:defRPr sz="1150" b="1">
+              <a:defRPr sz="1100">
                 <a:solidFill>
                   <a:srgbClr val="F1F5F9"/>
                 </a:solidFill>
               </a:defRPr>
             </a:pPr>
             <a:r>
-              <a:t>✔ Full-Stack Architecture:</a:t>
-            </a:r>
-          </a:p>
-          <a:p>
-            <a:pPr>
-              <a:defRPr sz="1050">
-                <a:solidFill>
-                  <a:srgbClr val="94A3B8"/>
-                </a:solidFill>
-              </a:defRPr>
-            </a:pPr>
-            <a:r>
-              <a:t>    Node.js/Express backend + React/Vite/Tailwind frontend.</a:t>
+              <a:t>• .gitignore isolates all .env, *.tfstate, and *.tfvars files</a:t>
             </a:r>
           </a:p>
           <a:p>
             <a:br/>
             <a:pPr>
-              <a:defRPr sz="1150" b="1">
+              <a:defRPr sz="1100">
                 <a:solidFill>
                   <a:srgbClr val="F1F5F9"/>
                 </a:solidFill>
               </a:defRPr>
             </a:pPr>
             <a:r>
-              <a:t>✔ Hybrid Cloud SDK:</a:t>
-            </a:r>
-          </a:p>
-          <a:p>
-            <a:pPr>
-              <a:defRPr sz="1050">
-                <a:solidFill>
-                  <a:srgbClr val="94A3B8"/>
-                </a:solidFill>
-              </a:defRPr>
-            </a:pPr>
-            <a:r>
-              <a:t>    Supports live AWS Cloud Services &amp; seamless in-memory simulator.</a:t>
+              <a:t>• Zero AWS Access Keys or secrets hardcoded in Git</a:t>
             </a:r>
           </a:p>
           <a:p>
             <a:br/>
             <a:pPr>
-              <a:defRPr sz="1150" b="1">
+              <a:defRPr sz="1100">
                 <a:solidFill>
                   <a:srgbClr val="F1F5F9"/>
                 </a:solidFill>
               </a:defRPr>
             </a:pPr>
             <a:r>
-              <a:t>✔ Live GitHub Deployment:</a:t>
-            </a:r>
-          </a:p>
-          <a:p>
-            <a:pPr>
-              <a:defRPr sz="1050">
-                <a:solidFill>
-                  <a:srgbClr val="94A3B8"/>
-                </a:solidFill>
-              </a:defRPr>
-            </a:pPr>
-            <a:r>
-              <a:t>    Accessible publicly on GitHub Pages.</a:t>
-            </a:r>
-          </a:p>
-          <a:p>
-            <a:br/>
-            <a:pPr>
-              <a:defRPr sz="1150" b="1">
-                <a:solidFill>
-                  <a:srgbClr val="F1F5F9"/>
-                </a:solidFill>
-              </a:defRPr>
-            </a:pPr>
-            <a:r>
-              <a:t>✔ Interactive Sensor Streams:</a:t>
-            </a:r>
-          </a:p>
-          <a:p>
-            <a:pPr>
-              <a:defRPr sz="1050">
-                <a:solidFill>
-                  <a:srgbClr val="94A3B8"/>
-                </a:solidFill>
-              </a:defRPr>
-            </a:pPr>
-            <a:r>
-              <a:t>    Real-time telemetry generator simulating trucks on transit routes.</a:t>
-            </a:r>
-          </a:p>
-          <a:p>
-            <a:br/>
-            <a:pPr>
-              <a:defRPr sz="1150" b="1">
-                <a:solidFill>
-                  <a:srgbClr val="F1F5F9"/>
-                </a:solidFill>
-              </a:defRPr>
-            </a:pPr>
-            <a:r>
-              <a:t>✔ Git Milestone Commits:</a:t>
-            </a:r>
-          </a:p>
-          <a:p>
-            <a:pPr>
-              <a:defRPr sz="1050">
-                <a:solidFill>
-                  <a:srgbClr val="94A3B8"/>
-                </a:solidFill>
-              </a:defRPr>
-            </a:pPr>
-            <a:r>
-              <a:t>    Modular commits on main tracking every build step.</a:t>
-            </a:r>
-          </a:p>
-        </p:txBody>
-      </p:sp>
-      <p:sp>
-        <p:nvSpPr>
-          <p:cNvPr id="6" name="Rounded Rectangle 5"/>
+              <a:t>• Anyone running code uses their own local AWS profile credentials</a:t>
+            </a:r>
+          </a:p>
+        </p:txBody>
+      </p:sp>
+      <p:sp>
+        <p:nvSpPr>
+          <p:cNvPr id="7" name="Rounded Rectangle 6"/>
           <p:cNvSpPr/>
           <p:nvPr/>
         </p:nvSpPr>
         <p:spPr>
           <a:xfrm>
-            <a:off x="6217920" y="1554480"/>
-            <a:ext cx="5212080" cy="4754880"/>
+            <a:off x="4343400" y="2834640"/>
+            <a:ext cx="3383280" cy="3474720"/>
           </a:xfrm>
           <a:prstGeom prst="roundRect">
             <a:avLst/>
@@ -5781,8 +5624,498 @@
           <a:lstStyle/>
           <a:p>
             <a:pPr algn="ctr">
+              <a:defRPr sz="1300" b="1">
+                <a:solidFill>
+                  <a:srgbClr val="22D3EE"/>
+                </a:solidFill>
+              </a:defRPr>
+            </a:pPr>
+            <a:r>
+              <a:t>2. Least-Privilege IAM</a:t>
+            </a:r>
+          </a:p>
+          <a:p>
+            <a:br/>
+            <a:pPr>
+              <a:defRPr sz="1100">
+                <a:solidFill>
+                  <a:srgbClr val="F1F5F9"/>
+                </a:solidFill>
+              </a:defRPr>
+            </a:pPr>
+            <a:r>
+              <a:t>• Lambda execution roles scoped strictly to specific SQS &amp; DynamoDB ARNs</a:t>
+            </a:r>
+          </a:p>
+          <a:p>
+            <a:br/>
+            <a:pPr>
+              <a:defRPr sz="1100">
+                <a:solidFill>
+                  <a:srgbClr val="F1F5F9"/>
+                </a:solidFill>
+              </a:defRPr>
+            </a:pPr>
+            <a:r>
+              <a:t>• S3 Bucket Public Access Block enabled to prevent data exposure</a:t>
+            </a:r>
+          </a:p>
+          <a:p>
+            <a:br/>
+            <a:pPr>
+              <a:defRPr sz="1100">
+                <a:solidFill>
+                  <a:srgbClr val="F1F5F9"/>
+                </a:solidFill>
+              </a:defRPr>
+            </a:pPr>
+            <a:r>
+              <a:t>• Server-side encryption enabled by default (SSE-S3 AES-256)</a:t>
+            </a:r>
+          </a:p>
+        </p:txBody>
+      </p:sp>
+      <p:sp>
+        <p:nvSpPr>
+          <p:cNvPr id="8" name="Rounded Rectangle 7"/>
+          <p:cNvSpPr/>
+          <p:nvPr/>
+        </p:nvSpPr>
+        <p:spPr>
+          <a:xfrm>
+            <a:off x="7955280" y="2834640"/>
+            <a:ext cx="3383280" cy="3474720"/>
+          </a:xfrm>
+          <a:prstGeom prst="roundRect">
+            <a:avLst/>
+          </a:prstGeom>
+          <a:solidFill>
+            <a:srgbClr val="1A2438"/>
+          </a:solidFill>
+          <a:ln>
+            <a:noFill/>
+          </a:ln>
+        </p:spPr>
+        <p:style>
+          <a:lnRef idx="1">
+            <a:schemeClr val="accent1"/>
+          </a:lnRef>
+          <a:fillRef idx="3">
+            <a:schemeClr val="accent1"/>
+          </a:fillRef>
+          <a:effectRef idx="2">
+            <a:schemeClr val="accent1"/>
+          </a:effectRef>
+          <a:fontRef idx="minor">
+            <a:schemeClr val="lt1"/>
+          </a:fontRef>
+        </p:style>
+        <p:txBody>
+          <a:bodyPr rtlCol="0" anchor="ctr" wrap="square"/>
+          <a:lstStyle/>
+          <a:p>
+            <a:pPr algn="ctr">
+              <a:defRPr sz="1300" b="1">
+                <a:solidFill>
+                  <a:srgbClr val="22D3EE"/>
+                </a:solidFill>
+              </a:defRPr>
+            </a:pPr>
+            <a:r>
+              <a:t>3. Automated CI/CD</a:t>
+            </a:r>
+          </a:p>
+          <a:p>
+            <a:br/>
+            <a:pPr>
+              <a:defRPr sz="1100">
+                <a:solidFill>
+                  <a:srgbClr val="F1F5F9"/>
+                </a:solidFill>
+              </a:defRPr>
+            </a:pPr>
+            <a:r>
+              <a:t>• GitHub Actions runs terraform fmt &amp; syntax validation on every push</a:t>
+            </a:r>
+          </a:p>
+          <a:p>
+            <a:br/>
+            <a:pPr>
+              <a:defRPr sz="1100">
+                <a:solidFill>
+                  <a:srgbClr val="F1F5F9"/>
+                </a:solidFill>
+              </a:defRPr>
+            </a:pPr>
+            <a:r>
+              <a:t>• Automated builds for both backend API and React frontend</a:t>
+            </a:r>
+          </a:p>
+          <a:p>
+            <a:br/>
+            <a:pPr>
+              <a:defRPr sz="1100">
+                <a:solidFill>
+                  <a:srgbClr val="F1F5F9"/>
+                </a:solidFill>
+              </a:defRPr>
+            </a:pPr>
+            <a:r>
+              <a:t>• Zero-downtime static deployment to GitHub Pages CDN</a:t>
+            </a:r>
+          </a:p>
+        </p:txBody>
+      </p:sp>
+    </p:spTree>
+  </p:cSld>
+  <p:clrMapOvr>
+    <a:masterClrMapping/>
+  </p:clrMapOvr>
+</p:sld>
+</file>
+
+<file path=ppt/slides/slide7.xml><?xml version="1.0" encoding="utf-8"?>
+<p:sld xmlns:a="http://schemas.openxmlformats.org/drawingml/2006/main" xmlns:p="http://schemas.openxmlformats.org/presentationml/2006/main" xmlns:r="http://schemas.openxmlformats.org/officeDocument/2006/relationships">
+  <p:cSld>
+    <p:spTree>
+      <p:nvGrpSpPr>
+        <p:cNvPr id="1" name=""/>
+        <p:cNvGrpSpPr/>
+        <p:nvPr/>
+      </p:nvGrpSpPr>
+      <p:grpSpPr/>
+      <p:sp>
+        <p:nvSpPr>
+          <p:cNvPr id="2" name="Rectangle 1"/>
+          <p:cNvSpPr/>
+          <p:nvPr/>
+        </p:nvSpPr>
+        <p:spPr>
+          <a:xfrm>
+            <a:off x="0" y="0"/>
+            <a:ext cx="12191695" cy="6858000"/>
+          </a:xfrm>
+          <a:prstGeom prst="rect">
+            <a:avLst/>
+          </a:prstGeom>
+          <a:solidFill>
+            <a:srgbClr val="0B1120"/>
+          </a:solidFill>
+          <a:ln>
+            <a:noFill/>
+          </a:ln>
+        </p:spPr>
+        <p:style>
+          <a:lnRef idx="1">
+            <a:schemeClr val="accent1"/>
+          </a:lnRef>
+          <a:fillRef idx="3">
+            <a:schemeClr val="accent1"/>
+          </a:fillRef>
+          <a:effectRef idx="2">
+            <a:schemeClr val="accent1"/>
+          </a:effectRef>
+          <a:fontRef idx="minor">
+            <a:schemeClr val="lt1"/>
+          </a:fontRef>
+        </p:style>
+        <p:txBody>
+          <a:bodyPr rtlCol="0" anchor="ctr"/>
+          <a:lstStyle/>
+          <a:p>
+            <a:pPr algn="ctr"/>
+          </a:p>
+        </p:txBody>
+      </p:sp>
+      <p:sp>
+        <p:nvSpPr>
+          <p:cNvPr id="3" name="TextBox 2"/>
+          <p:cNvSpPr txBox="1"/>
+          <p:nvPr/>
+        </p:nvSpPr>
+        <p:spPr>
+          <a:xfrm>
+            <a:off x="731520" y="365760"/>
+            <a:ext cx="10698480" cy="365760"/>
+          </a:xfrm>
+          <a:prstGeom prst="rect">
+            <a:avLst/>
+          </a:prstGeom>
+          <a:noFill/>
+        </p:spPr>
+        <p:txBody>
+          <a:bodyPr wrap="square">
+            <a:spAutoFit/>
+          </a:bodyPr>
+          <a:lstStyle/>
+          <a:p>
+            <a:pPr>
+              <a:defRPr sz="1100" b="1">
+                <a:solidFill>
+                  <a:srgbClr val="FF9900"/>
+                </a:solidFill>
+              </a:defRPr>
+            </a:pPr>
+            <a:r>
+              <a:t>RESULTS &amp; HORIZONS</a:t>
+            </a:r>
+          </a:p>
+        </p:txBody>
+      </p:sp>
+      <p:sp>
+        <p:nvSpPr>
+          <p:cNvPr id="4" name="TextBox 3"/>
+          <p:cNvSpPr txBox="1"/>
+          <p:nvPr/>
+        </p:nvSpPr>
+        <p:spPr>
+          <a:xfrm>
+            <a:off x="731520" y="640080"/>
+            <a:ext cx="10698480" cy="731520"/>
+          </a:xfrm>
+          <a:prstGeom prst="rect">
+            <a:avLst/>
+          </a:prstGeom>
+          <a:noFill/>
+        </p:spPr>
+        <p:txBody>
+          <a:bodyPr wrap="square">
+            <a:spAutoFit/>
+          </a:bodyPr>
+          <a:lstStyle/>
+          <a:p>
+            <a:pPr>
+              <a:defRPr sz="2600" b="1">
+                <a:solidFill>
+                  <a:srgbClr val="F1F5F9"/>
+                </a:solidFill>
+              </a:defRPr>
+            </a:pPr>
+            <a:r>
+              <a:t>Project Deliverables, Live Demo &amp; Future Roadmap</a:t>
+            </a:r>
+          </a:p>
+        </p:txBody>
+      </p:sp>
+      <p:sp>
+        <p:nvSpPr>
+          <p:cNvPr id="5" name="Rounded Rectangle 4"/>
+          <p:cNvSpPr/>
+          <p:nvPr/>
+        </p:nvSpPr>
+        <p:spPr>
+          <a:xfrm>
+            <a:off x="731520" y="1554480"/>
+            <a:ext cx="5120640" cy="4754880"/>
+          </a:xfrm>
+          <a:prstGeom prst="roundRect">
+            <a:avLst/>
+          </a:prstGeom>
+          <a:solidFill>
+            <a:srgbClr val="1A2438"/>
+          </a:solidFill>
+          <a:ln>
+            <a:noFill/>
+          </a:ln>
+        </p:spPr>
+        <p:style>
+          <a:lnRef idx="1">
+            <a:schemeClr val="accent1"/>
+          </a:lnRef>
+          <a:fillRef idx="3">
+            <a:schemeClr val="accent1"/>
+          </a:fillRef>
+          <a:effectRef idx="2">
+            <a:schemeClr val="accent1"/>
+          </a:effectRef>
+          <a:fontRef idx="minor">
+            <a:schemeClr val="lt1"/>
+          </a:fontRef>
+        </p:style>
+        <p:txBody>
+          <a:bodyPr rtlCol="0" anchor="ctr" wrap="square"/>
+          <a:lstStyle/>
+          <a:p>
+            <a:pPr algn="ctr">
               <a:defRPr sz="1500" b="1">
                 <a:solidFill>
+                  <a:srgbClr val="34D399"/>
+                </a:solidFill>
+              </a:defRPr>
+            </a:pPr>
+            <a:r>
+              <a:t>📈 Key Engineering Deliverables</a:t>
+            </a:r>
+          </a:p>
+          <a:p>
+            <a:br/>
+            <a:pPr>
+              <a:defRPr sz="1150" b="1">
+                <a:solidFill>
+                  <a:srgbClr val="F1F5F9"/>
+                </a:solidFill>
+              </a:defRPr>
+            </a:pPr>
+            <a:r>
+              <a:t>✔ Full-Stack Architecture:</a:t>
+            </a:r>
+          </a:p>
+          <a:p>
+            <a:pPr>
+              <a:defRPr sz="1050">
+                <a:solidFill>
+                  <a:srgbClr val="94A3B8"/>
+                </a:solidFill>
+              </a:defRPr>
+            </a:pPr>
+            <a:r>
+              <a:t>    Node.js/Express backend + React/Vite/Tailwind frontend.</a:t>
+            </a:r>
+          </a:p>
+          <a:p>
+            <a:br/>
+            <a:pPr>
+              <a:defRPr sz="1150" b="1">
+                <a:solidFill>
+                  <a:srgbClr val="F1F5F9"/>
+                </a:solidFill>
+              </a:defRPr>
+            </a:pPr>
+            <a:r>
+              <a:t>✔ Hybrid Cloud SDK:</a:t>
+            </a:r>
+          </a:p>
+          <a:p>
+            <a:pPr>
+              <a:defRPr sz="1050">
+                <a:solidFill>
+                  <a:srgbClr val="94A3B8"/>
+                </a:solidFill>
+              </a:defRPr>
+            </a:pPr>
+            <a:r>
+              <a:t>    Supports live AWS Cloud Services &amp; seamless in-memory simulator.</a:t>
+            </a:r>
+          </a:p>
+          <a:p>
+            <a:br/>
+            <a:pPr>
+              <a:defRPr sz="1150" b="1">
+                <a:solidFill>
+                  <a:srgbClr val="F1F5F9"/>
+                </a:solidFill>
+              </a:defRPr>
+            </a:pPr>
+            <a:r>
+              <a:t>✔ Cryptographic Blockchain:</a:t>
+            </a:r>
+          </a:p>
+          <a:p>
+            <a:pPr>
+              <a:defRPr sz="1050">
+                <a:solidFill>
+                  <a:srgbClr val="94A3B8"/>
+                </a:solidFill>
+              </a:defRPr>
+            </a:pPr>
+            <a:r>
+              <a:t>    SHA-256 Merkle chain, smart contracts &amp; digital signatures.</a:t>
+            </a:r>
+          </a:p>
+          <a:p>
+            <a:br/>
+            <a:pPr>
+              <a:defRPr sz="1150" b="1">
+                <a:solidFill>
+                  <a:srgbClr val="F1F5F9"/>
+                </a:solidFill>
+              </a:defRPr>
+            </a:pPr>
+            <a:r>
+              <a:t>✔ Live GitHub Deployment:</a:t>
+            </a:r>
+          </a:p>
+          <a:p>
+            <a:pPr>
+              <a:defRPr sz="1050">
+                <a:solidFill>
+                  <a:srgbClr val="94A3B8"/>
+                </a:solidFill>
+              </a:defRPr>
+            </a:pPr>
+            <a:r>
+              <a:t>    Accessible publicly on GitHub Pages.</a:t>
+            </a:r>
+          </a:p>
+          <a:p>
+            <a:br/>
+            <a:pPr>
+              <a:defRPr sz="1150" b="1">
+                <a:solidFill>
+                  <a:srgbClr val="F1F5F9"/>
+                </a:solidFill>
+              </a:defRPr>
+            </a:pPr>
+            <a:r>
+              <a:t>✔ Interactive Sensor Streams:</a:t>
+            </a:r>
+          </a:p>
+          <a:p>
+            <a:pPr>
+              <a:defRPr sz="1050">
+                <a:solidFill>
+                  <a:srgbClr val="94A3B8"/>
+                </a:solidFill>
+              </a:defRPr>
+            </a:pPr>
+            <a:r>
+              <a:t>    Real-time telemetry generator simulating trucks on transit routes.</a:t>
+            </a:r>
+          </a:p>
+        </p:txBody>
+      </p:sp>
+      <p:sp>
+        <p:nvSpPr>
+          <p:cNvPr id="6" name="Rounded Rectangle 5"/>
+          <p:cNvSpPr/>
+          <p:nvPr/>
+        </p:nvSpPr>
+        <p:spPr>
+          <a:xfrm>
+            <a:off x="6217920" y="1554480"/>
+            <a:ext cx="5212080" cy="4754880"/>
+          </a:xfrm>
+          <a:prstGeom prst="roundRect">
+            <a:avLst/>
+          </a:prstGeom>
+          <a:solidFill>
+            <a:srgbClr val="1A2438"/>
+          </a:solidFill>
+          <a:ln>
+            <a:noFill/>
+          </a:ln>
+        </p:spPr>
+        <p:style>
+          <a:lnRef idx="1">
+            <a:schemeClr val="accent1"/>
+          </a:lnRef>
+          <a:fillRef idx="3">
+            <a:schemeClr val="accent1"/>
+          </a:fillRef>
+          <a:effectRef idx="2">
+            <a:schemeClr val="accent1"/>
+          </a:effectRef>
+          <a:fontRef idx="minor">
+            <a:schemeClr val="lt1"/>
+          </a:fontRef>
+        </p:style>
+        <p:txBody>
+          <a:bodyPr rtlCol="0" anchor="ctr" wrap="square"/>
+          <a:lstStyle/>
+          <a:p>
+            <a:pPr algn="ctr">
+              <a:defRPr sz="1500" b="1">
+                <a:solidFill>
                   <a:srgbClr val="FF9900"/>
                 </a:solidFill>
               </a:defRPr>
@@ -5859,7 +6192,7 @@
               </a:defRPr>
             </a:pPr>
             <a:r>
-              <a:t> • Amazon QuickSight executive business intelligence dashboards</a:t>
+              <a:t> • Multi-organization Hyperledger Fabric channel network</a:t>
             </a:r>
           </a:p>
           <a:p>

</xml_diff>